<commit_message>
Add execution time m_ware
</commit_message>
<xml_diff>
--- a/Documentation/Figures/Latency and Response Time - Copy.pptx
+++ b/Documentation/Figures/Latency and Response Time - Copy.pptx
@@ -259,7 +259,7 @@
           <a:p>
             <a:fld id="{2231E127-0FFC-443A-B14E-CEAC92C6D946}" type="datetimeFigureOut">
               <a:rPr lang="en-US" smtClean="0"/>
-              <a:t>4/3/2023</a:t>
+              <a:t>4/12/2023</a:t>
             </a:fld>
             <a:endParaRPr lang="en-US"/>
           </a:p>
@@ -457,7 +457,7 @@
           <a:p>
             <a:fld id="{2231E127-0FFC-443A-B14E-CEAC92C6D946}" type="datetimeFigureOut">
               <a:rPr lang="en-US" smtClean="0"/>
-              <a:t>4/3/2023</a:t>
+              <a:t>4/12/2023</a:t>
             </a:fld>
             <a:endParaRPr lang="en-US"/>
           </a:p>
@@ -665,7 +665,7 @@
           <a:p>
             <a:fld id="{2231E127-0FFC-443A-B14E-CEAC92C6D946}" type="datetimeFigureOut">
               <a:rPr lang="en-US" smtClean="0"/>
-              <a:t>4/3/2023</a:t>
+              <a:t>4/12/2023</a:t>
             </a:fld>
             <a:endParaRPr lang="en-US"/>
           </a:p>
@@ -863,7 +863,7 @@
           <a:p>
             <a:fld id="{2231E127-0FFC-443A-B14E-CEAC92C6D946}" type="datetimeFigureOut">
               <a:rPr lang="en-US" smtClean="0"/>
-              <a:t>4/3/2023</a:t>
+              <a:t>4/12/2023</a:t>
             </a:fld>
             <a:endParaRPr lang="en-US"/>
           </a:p>
@@ -1138,7 +1138,7 @@
           <a:p>
             <a:fld id="{2231E127-0FFC-443A-B14E-CEAC92C6D946}" type="datetimeFigureOut">
               <a:rPr lang="en-US" smtClean="0"/>
-              <a:t>4/3/2023</a:t>
+              <a:t>4/12/2023</a:t>
             </a:fld>
             <a:endParaRPr lang="en-US"/>
           </a:p>
@@ -1403,7 +1403,7 @@
           <a:p>
             <a:fld id="{2231E127-0FFC-443A-B14E-CEAC92C6D946}" type="datetimeFigureOut">
               <a:rPr lang="en-US" smtClean="0"/>
-              <a:t>4/3/2023</a:t>
+              <a:t>4/12/2023</a:t>
             </a:fld>
             <a:endParaRPr lang="en-US"/>
           </a:p>
@@ -1815,7 +1815,7 @@
           <a:p>
             <a:fld id="{2231E127-0FFC-443A-B14E-CEAC92C6D946}" type="datetimeFigureOut">
               <a:rPr lang="en-US" smtClean="0"/>
-              <a:t>4/3/2023</a:t>
+              <a:t>4/12/2023</a:t>
             </a:fld>
             <a:endParaRPr lang="en-US"/>
           </a:p>
@@ -1956,7 +1956,7 @@
           <a:p>
             <a:fld id="{2231E127-0FFC-443A-B14E-CEAC92C6D946}" type="datetimeFigureOut">
               <a:rPr lang="en-US" smtClean="0"/>
-              <a:t>4/3/2023</a:t>
+              <a:t>4/12/2023</a:t>
             </a:fld>
             <a:endParaRPr lang="en-US"/>
           </a:p>
@@ -2069,7 +2069,7 @@
           <a:p>
             <a:fld id="{2231E127-0FFC-443A-B14E-CEAC92C6D946}" type="datetimeFigureOut">
               <a:rPr lang="en-US" smtClean="0"/>
-              <a:t>4/3/2023</a:t>
+              <a:t>4/12/2023</a:t>
             </a:fld>
             <a:endParaRPr lang="en-US"/>
           </a:p>
@@ -2380,7 +2380,7 @@
           <a:p>
             <a:fld id="{2231E127-0FFC-443A-B14E-CEAC92C6D946}" type="datetimeFigureOut">
               <a:rPr lang="en-US" smtClean="0"/>
-              <a:t>4/3/2023</a:t>
+              <a:t>4/12/2023</a:t>
             </a:fld>
             <a:endParaRPr lang="en-US"/>
           </a:p>
@@ -2668,7 +2668,7 @@
           <a:p>
             <a:fld id="{2231E127-0FFC-443A-B14E-CEAC92C6D946}" type="datetimeFigureOut">
               <a:rPr lang="en-US" smtClean="0"/>
-              <a:t>4/3/2023</a:t>
+              <a:t>4/12/2023</a:t>
             </a:fld>
             <a:endParaRPr lang="en-US"/>
           </a:p>
@@ -2909,7 +2909,7 @@
           <a:p>
             <a:fld id="{2231E127-0FFC-443A-B14E-CEAC92C6D946}" type="datetimeFigureOut">
               <a:rPr lang="en-US" smtClean="0"/>
-              <a:t>4/3/2023</a:t>
+              <a:t>4/12/2023</a:t>
             </a:fld>
             <a:endParaRPr lang="en-US"/>
           </a:p>
@@ -4396,8 +4396,8 @@
           </p:nvSpPr>
           <p:spPr>
             <a:xfrm>
-              <a:off x="4103404" y="5683223"/>
-              <a:ext cx="4211698" cy="646331"/>
+              <a:off x="3325401" y="5683223"/>
+              <a:ext cx="5767734" cy="646331"/>
             </a:xfrm>
             <a:prstGeom prst="rect">
               <a:avLst/>
@@ -4413,14 +4413,14 @@
               <a:pPr algn="ctr"/>
               <a:r>
                 <a:rPr lang="en-US" dirty="0"/>
-                <a:t>Client Side</a:t>
+                <a:t>Client-to-Middleware</a:t>
               </a:r>
             </a:p>
             <a:p>
               <a:pPr algn="ctr"/>
               <a:r>
                 <a:rPr lang="en-US" dirty="0"/>
-                <a:t>Response Time</a:t>
+                <a:t>Round-trip Latency</a:t>
               </a:r>
             </a:p>
           </p:txBody>
@@ -4741,8 +4741,8 @@
           </p:nvSpPr>
           <p:spPr>
             <a:xfrm>
-              <a:off x="4743570" y="5971042"/>
-              <a:ext cx="2931375" cy="369332"/>
+              <a:off x="4623649" y="5971042"/>
+              <a:ext cx="3171219" cy="369332"/>
             </a:xfrm>
             <a:prstGeom prst="rect">
               <a:avLst/>
@@ -4758,7 +4758,7 @@
               <a:pPr algn="ctr"/>
               <a:r>
                 <a:rPr lang="en-US" dirty="0"/>
-                <a:t>Middleware-Databases Response Time</a:t>
+                <a:t>Middleware-to-Databases Response Time</a:t>
               </a:r>
             </a:p>
           </p:txBody>
@@ -4778,10 +4778,10 @@
         </p:nvGrpSpPr>
         <p:grpSpPr>
           <a:xfrm>
-            <a:off x="7799643" y="4305136"/>
-            <a:ext cx="2150210" cy="386552"/>
-            <a:chOff x="3225518" y="5964866"/>
-            <a:chExt cx="6083995" cy="386552"/>
+            <a:off x="7799643" y="4034420"/>
+            <a:ext cx="2150210" cy="657268"/>
+            <a:chOff x="3225518" y="5694150"/>
+            <a:chExt cx="6083995" cy="657268"/>
           </a:xfrm>
         </p:grpSpPr>
         <p:cxnSp>
@@ -4812,7 +4812,7 @@
               </a:solidFill>
               <a:prstDash val="solid"/>
               <a:round/>
-              <a:headEnd type="none" w="med" len="med"/>
+              <a:headEnd type="triangle" w="med" len="med"/>
               <a:tailEnd type="triangle" w="med" len="med"/>
             </a:ln>
           </p:spPr>
@@ -4845,8 +4845,8 @@
           </p:nvSpPr>
           <p:spPr>
             <a:xfrm>
-              <a:off x="4048686" y="5964866"/>
-              <a:ext cx="4451309" cy="369332"/>
+              <a:off x="3490890" y="5694150"/>
+              <a:ext cx="5566914" cy="646331"/>
             </a:xfrm>
             <a:prstGeom prst="rect">
               <a:avLst/>
@@ -4862,7 +4862,14 @@
               <a:pPr algn="ctr"/>
               <a:r>
                 <a:rPr lang="en-US" dirty="0"/>
-                <a:t>Internal Latency</a:t>
+                <a:t>Internal </a:t>
+              </a:r>
+            </a:p>
+            <a:p>
+              <a:pPr algn="ctr"/>
+              <a:r>
+                <a:rPr lang="en-US" dirty="0"/>
+                <a:t>Round-trip Latency</a:t>
               </a:r>
             </a:p>
           </p:txBody>
@@ -5014,53 +5021,6 @@
           </p:txBody>
         </p:sp>
       </p:grpSp>
-      <p:cxnSp>
-        <p:nvCxnSpPr>
-          <p:cNvPr id="5" name="Straight Arrow Connector 4">
-            <a:extLst>
-              <a:ext uri="{FF2B5EF4-FFF2-40B4-BE49-F238E27FC236}">
-                <a16:creationId xmlns:a16="http://schemas.microsoft.com/office/drawing/2014/main" id="{BDC5FAB4-2D4A-C9FE-9BE0-AA3007943EE1}"/>
-              </a:ext>
-            </a:extLst>
-          </p:cNvPr>
-          <p:cNvCxnSpPr>
-            <a:cxnSpLocks/>
-          </p:cNvCxnSpPr>
-          <p:nvPr/>
-        </p:nvCxnSpPr>
-        <p:spPr>
-          <a:xfrm flipH="1">
-            <a:off x="7793466" y="4807992"/>
-            <a:ext cx="2154370" cy="0"/>
-          </a:xfrm>
-          <a:prstGeom prst="straightConnector1">
-            <a:avLst/>
-          </a:prstGeom>
-          <a:ln w="28575" cap="flat" cmpd="sng" algn="ctr">
-            <a:solidFill>
-              <a:schemeClr val="dk1"/>
-            </a:solidFill>
-            <a:prstDash val="solid"/>
-            <a:round/>
-            <a:headEnd type="none" w="med" len="med"/>
-            <a:tailEnd type="triangle" w="med" len="med"/>
-          </a:ln>
-        </p:spPr>
-        <p:style>
-          <a:lnRef idx="0">
-            <a:scrgbClr r="0" g="0" b="0"/>
-          </a:lnRef>
-          <a:fillRef idx="0">
-            <a:scrgbClr r="0" g="0" b="0"/>
-          </a:fillRef>
-          <a:effectRef idx="0">
-            <a:scrgbClr r="0" g="0" b="0"/>
-          </a:effectRef>
-          <a:fontRef idx="minor">
-            <a:schemeClr val="tx1"/>
-          </a:fontRef>
-        </p:style>
-      </p:cxnSp>
     </p:spTree>
     <p:extLst>
       <p:ext uri="{BB962C8B-B14F-4D97-AF65-F5344CB8AC3E}">

</xml_diff>

<commit_message>
Add all visualizations and fine grain profiling
</commit_message>
<xml_diff>
--- a/Documentation/Figures/Latency and Response Time - Copy.pptx
+++ b/Documentation/Figures/Latency and Response Time - Copy.pptx
@@ -259,7 +259,7 @@
           <a:p>
             <a:fld id="{2231E127-0FFC-443A-B14E-CEAC92C6D946}" type="datetimeFigureOut">
               <a:rPr lang="en-US" smtClean="0"/>
-              <a:t>4/12/2023</a:t>
+              <a:t>4/20/2023</a:t>
             </a:fld>
             <a:endParaRPr lang="en-US"/>
           </a:p>
@@ -457,7 +457,7 @@
           <a:p>
             <a:fld id="{2231E127-0FFC-443A-B14E-CEAC92C6D946}" type="datetimeFigureOut">
               <a:rPr lang="en-US" smtClean="0"/>
-              <a:t>4/12/2023</a:t>
+              <a:t>4/20/2023</a:t>
             </a:fld>
             <a:endParaRPr lang="en-US"/>
           </a:p>
@@ -665,7 +665,7 @@
           <a:p>
             <a:fld id="{2231E127-0FFC-443A-B14E-CEAC92C6D946}" type="datetimeFigureOut">
               <a:rPr lang="en-US" smtClean="0"/>
-              <a:t>4/12/2023</a:t>
+              <a:t>4/20/2023</a:t>
             </a:fld>
             <a:endParaRPr lang="en-US"/>
           </a:p>
@@ -863,7 +863,7 @@
           <a:p>
             <a:fld id="{2231E127-0FFC-443A-B14E-CEAC92C6D946}" type="datetimeFigureOut">
               <a:rPr lang="en-US" smtClean="0"/>
-              <a:t>4/12/2023</a:t>
+              <a:t>4/20/2023</a:t>
             </a:fld>
             <a:endParaRPr lang="en-US"/>
           </a:p>
@@ -1138,7 +1138,7 @@
           <a:p>
             <a:fld id="{2231E127-0FFC-443A-B14E-CEAC92C6D946}" type="datetimeFigureOut">
               <a:rPr lang="en-US" smtClean="0"/>
-              <a:t>4/12/2023</a:t>
+              <a:t>4/20/2023</a:t>
             </a:fld>
             <a:endParaRPr lang="en-US"/>
           </a:p>
@@ -1403,7 +1403,7 @@
           <a:p>
             <a:fld id="{2231E127-0FFC-443A-B14E-CEAC92C6D946}" type="datetimeFigureOut">
               <a:rPr lang="en-US" smtClean="0"/>
-              <a:t>4/12/2023</a:t>
+              <a:t>4/20/2023</a:t>
             </a:fld>
             <a:endParaRPr lang="en-US"/>
           </a:p>
@@ -1815,7 +1815,7 @@
           <a:p>
             <a:fld id="{2231E127-0FFC-443A-B14E-CEAC92C6D946}" type="datetimeFigureOut">
               <a:rPr lang="en-US" smtClean="0"/>
-              <a:t>4/12/2023</a:t>
+              <a:t>4/20/2023</a:t>
             </a:fld>
             <a:endParaRPr lang="en-US"/>
           </a:p>
@@ -1956,7 +1956,7 @@
           <a:p>
             <a:fld id="{2231E127-0FFC-443A-B14E-CEAC92C6D946}" type="datetimeFigureOut">
               <a:rPr lang="en-US" smtClean="0"/>
-              <a:t>4/12/2023</a:t>
+              <a:t>4/20/2023</a:t>
             </a:fld>
             <a:endParaRPr lang="en-US"/>
           </a:p>
@@ -2069,7 +2069,7 @@
           <a:p>
             <a:fld id="{2231E127-0FFC-443A-B14E-CEAC92C6D946}" type="datetimeFigureOut">
               <a:rPr lang="en-US" smtClean="0"/>
-              <a:t>4/12/2023</a:t>
+              <a:t>4/20/2023</a:t>
             </a:fld>
             <a:endParaRPr lang="en-US"/>
           </a:p>
@@ -2380,7 +2380,7 @@
           <a:p>
             <a:fld id="{2231E127-0FFC-443A-B14E-CEAC92C6D946}" type="datetimeFigureOut">
               <a:rPr lang="en-US" smtClean="0"/>
-              <a:t>4/12/2023</a:t>
+              <a:t>4/20/2023</a:t>
             </a:fld>
             <a:endParaRPr lang="en-US"/>
           </a:p>
@@ -2668,7 +2668,7 @@
           <a:p>
             <a:fld id="{2231E127-0FFC-443A-B14E-CEAC92C6D946}" type="datetimeFigureOut">
               <a:rPr lang="en-US" smtClean="0"/>
-              <a:t>4/12/2023</a:t>
+              <a:t>4/20/2023</a:t>
             </a:fld>
             <a:endParaRPr lang="en-US"/>
           </a:p>
@@ -2909,7 +2909,7 @@
           <a:p>
             <a:fld id="{2231E127-0FFC-443A-B14E-CEAC92C6D946}" type="datetimeFigureOut">
               <a:rPr lang="en-US" smtClean="0"/>
-              <a:t>4/12/2023</a:t>
+              <a:t>4/20/2023</a:t>
             </a:fld>
             <a:endParaRPr lang="en-US"/>
           </a:p>
@@ -4679,8 +4679,8 @@
         </p:nvGrpSpPr>
         <p:grpSpPr>
           <a:xfrm>
-            <a:off x="3967669" y="5137465"/>
-            <a:ext cx="7912919" cy="380376"/>
+            <a:off x="7813317" y="5510446"/>
+            <a:ext cx="4067271" cy="380376"/>
             <a:chOff x="3225518" y="5971042"/>
             <a:chExt cx="6083995" cy="380376"/>
           </a:xfrm>
@@ -4891,8 +4891,8 @@
         </p:nvCxnSpPr>
         <p:spPr>
           <a:xfrm>
-            <a:off x="7800328" y="1844365"/>
-            <a:ext cx="6448" cy="3072347"/>
+            <a:off x="7806344" y="1970694"/>
+            <a:ext cx="272" cy="4123298"/>
           </a:xfrm>
           <a:prstGeom prst="line">
             <a:avLst/>
@@ -4936,7 +4936,7 @@
         </p:nvGrpSpPr>
         <p:grpSpPr>
           <a:xfrm>
-            <a:off x="3965607" y="4170820"/>
+            <a:off x="3965607" y="4182852"/>
             <a:ext cx="3841169" cy="404631"/>
             <a:chOff x="-621078" y="5980364"/>
             <a:chExt cx="10868544" cy="404631"/>

</xml_diff>